<commit_message>
update presentation and ignore office lock files
</commit_message>
<xml_diff>
--- a/INFERCTRL_Presentation.pptx
+++ b/INFERCTRL_Presentation.pptx
@@ -5,18 +5,18 @@
     <p:sldMasterId id="2147483648" r:id="rId1"/>
   </p:sldMasterIdLst>
   <p:sldIdLst>
-    <p:sldId id="256" r:id="rId7"/>
-    <p:sldId id="257" r:id="rId8"/>
-    <p:sldId id="258" r:id="rId9"/>
-    <p:sldId id="259" r:id="rId10"/>
-    <p:sldId id="260" r:id="rId11"/>
-    <p:sldId id="261" r:id="rId12"/>
-    <p:sldId id="262" r:id="rId13"/>
-    <p:sldId id="263" r:id="rId14"/>
-    <p:sldId id="264" r:id="rId15"/>
-    <p:sldId id="265" r:id="rId16"/>
+    <p:sldId id="256" r:id="rId2"/>
+    <p:sldId id="257" r:id="rId3"/>
+    <p:sldId id="258" r:id="rId4"/>
+    <p:sldId id="259" r:id="rId5"/>
+    <p:sldId id="260" r:id="rId6"/>
+    <p:sldId id="261" r:id="rId7"/>
+    <p:sldId id="262" r:id="rId8"/>
+    <p:sldId id="263" r:id="rId9"/>
+    <p:sldId id="264" r:id="rId10"/>
+    <p:sldId id="265" r:id="rId11"/>
   </p:sldIdLst>
-  <p:sldSz cx="12188952" cy="6858000" type="screen4x3"/>
+  <p:sldSz cx="12188825" cy="6858000"/>
   <p:notesSz cx="6858000" cy="9144000"/>
   <p:defaultTextStyle>
     <a:defPPr>
@@ -113,6 +113,22 @@
       </a:defRPr>
     </a:lvl9pPr>
   </p:defaultTextStyle>
+  <p:extLst>
+    <p:ext uri="{EFAFB233-063F-42B5-8137-9DF3F51BA10A}">
+      <p15:sldGuideLst xmlns:p15="http://schemas.microsoft.com/office/powerpoint/2012/main">
+        <p15:guide id="1" orient="horz" pos="2160">
+          <p15:clr>
+            <a:srgbClr val="A4A3A4"/>
+          </p15:clr>
+        </p15:guide>
+        <p15:guide id="2" pos="2880">
+          <p15:clr>
+            <a:srgbClr val="A4A3A4"/>
+          </p15:clr>
+        </p15:guide>
+      </p15:sldGuideLst>
+    </p:ext>
+  </p:extLst>
 </p:presentation>
 </file>
 
@@ -154,10 +170,9 @@
           <a:lstStyle/>
           <a:p>
             <a:r>
-              <a:rPr lang="en-US" smtClean="0"/>
+              <a:rPr lang="en-US"/>
               <a:t>Click to edit Master title style</a:t>
             </a:r>
-            <a:endParaRPr lang="en-US"/>
           </a:p>
         </p:txBody>
       </p:sp>
@@ -273,10 +288,9 @@
           </a:lstStyle>
           <a:p>
             <a:r>
-              <a:rPr lang="en-US" smtClean="0"/>
+              <a:rPr lang="en-US"/>
               <a:t>Click to edit Master subtitle style</a:t>
             </a:r>
-            <a:endParaRPr lang="en-US"/>
           </a:p>
         </p:txBody>
       </p:sp>
@@ -297,7 +311,7 @@
           <a:p>
             <a:fld id="{5BCAD085-E8A6-8845-BD4E-CB4CCA059FC4}" type="datetimeFigureOut">
               <a:rPr lang="en-US" smtClean="0"/>
-              <a:t>1/27/13</a:t>
+              <a:t>10/29/2026</a:t>
             </a:fld>
             <a:endParaRPr lang="en-US"/>
           </a:p>
@@ -391,10 +405,9 @@
           <a:lstStyle/>
           <a:p>
             <a:r>
-              <a:rPr lang="en-US" smtClean="0"/>
+              <a:rPr lang="en-US"/>
               <a:t>Click to edit Master title style</a:t>
             </a:r>
-            <a:endParaRPr lang="en-US"/>
           </a:p>
         </p:txBody>
       </p:sp>
@@ -415,38 +428,37 @@
           <a:p>
             <a:pPr lvl="0"/>
             <a:r>
-              <a:rPr lang="en-US" smtClean="0"/>
+              <a:rPr lang="en-US"/>
               <a:t>Click to edit Master text styles</a:t>
             </a:r>
           </a:p>
           <a:p>
             <a:pPr lvl="1"/>
             <a:r>
-              <a:rPr lang="en-US" smtClean="0"/>
+              <a:rPr lang="en-US"/>
               <a:t>Second level</a:t>
             </a:r>
           </a:p>
           <a:p>
             <a:pPr lvl="2"/>
             <a:r>
-              <a:rPr lang="en-US" smtClean="0"/>
+              <a:rPr lang="en-US"/>
               <a:t>Third level</a:t>
             </a:r>
           </a:p>
           <a:p>
             <a:pPr lvl="3"/>
             <a:r>
-              <a:rPr lang="en-US" smtClean="0"/>
+              <a:rPr lang="en-US"/>
               <a:t>Fourth level</a:t>
             </a:r>
           </a:p>
           <a:p>
             <a:pPr lvl="4"/>
             <a:r>
-              <a:rPr lang="en-US" smtClean="0"/>
+              <a:rPr lang="en-US"/>
               <a:t>Fifth level</a:t>
             </a:r>
-            <a:endParaRPr lang="en-US"/>
           </a:p>
         </p:txBody>
       </p:sp>
@@ -467,7 +479,7 @@
           <a:p>
             <a:fld id="{5BCAD085-E8A6-8845-BD4E-CB4CCA059FC4}" type="datetimeFigureOut">
               <a:rPr lang="en-US" smtClean="0"/>
-              <a:t>1/27/13</a:t>
+              <a:t>10/29/2026</a:t>
             </a:fld>
             <a:endParaRPr lang="en-US"/>
           </a:p>
@@ -566,10 +578,9 @@
           <a:lstStyle/>
           <a:p>
             <a:r>
-              <a:rPr lang="en-US" smtClean="0"/>
+              <a:rPr lang="en-US"/>
               <a:t>Click to edit Master title style</a:t>
             </a:r>
-            <a:endParaRPr lang="en-US"/>
           </a:p>
         </p:txBody>
       </p:sp>
@@ -595,38 +606,37 @@
           <a:p>
             <a:pPr lvl="0"/>
             <a:r>
-              <a:rPr lang="en-US" smtClean="0"/>
+              <a:rPr lang="en-US"/>
               <a:t>Click to edit Master text styles</a:t>
             </a:r>
           </a:p>
           <a:p>
             <a:pPr lvl="1"/>
             <a:r>
-              <a:rPr lang="en-US" smtClean="0"/>
+              <a:rPr lang="en-US"/>
               <a:t>Second level</a:t>
             </a:r>
           </a:p>
           <a:p>
             <a:pPr lvl="2"/>
             <a:r>
-              <a:rPr lang="en-US" smtClean="0"/>
+              <a:rPr lang="en-US"/>
               <a:t>Third level</a:t>
             </a:r>
           </a:p>
           <a:p>
             <a:pPr lvl="3"/>
             <a:r>
-              <a:rPr lang="en-US" smtClean="0"/>
+              <a:rPr lang="en-US"/>
               <a:t>Fourth level</a:t>
             </a:r>
           </a:p>
           <a:p>
             <a:pPr lvl="4"/>
             <a:r>
-              <a:rPr lang="en-US" smtClean="0"/>
+              <a:rPr lang="en-US"/>
               <a:t>Fifth level</a:t>
             </a:r>
-            <a:endParaRPr lang="en-US"/>
           </a:p>
         </p:txBody>
       </p:sp>
@@ -647,7 +657,7 @@
           <a:p>
             <a:fld id="{5BCAD085-E8A6-8845-BD4E-CB4CCA059FC4}" type="datetimeFigureOut">
               <a:rPr lang="en-US" smtClean="0"/>
-              <a:t>1/27/13</a:t>
+              <a:t>10/29/2026</a:t>
             </a:fld>
             <a:endParaRPr lang="en-US"/>
           </a:p>
@@ -741,10 +751,9 @@
           <a:lstStyle/>
           <a:p>
             <a:r>
-              <a:rPr lang="en-US" smtClean="0"/>
+              <a:rPr lang="en-US"/>
               <a:t>Click to edit Master title style</a:t>
             </a:r>
-            <a:endParaRPr lang="en-US"/>
           </a:p>
         </p:txBody>
       </p:sp>
@@ -765,38 +774,37 @@
           <a:p>
             <a:pPr lvl="0"/>
             <a:r>
-              <a:rPr lang="en-US" smtClean="0"/>
+              <a:rPr lang="en-US"/>
               <a:t>Click to edit Master text styles</a:t>
             </a:r>
           </a:p>
           <a:p>
             <a:pPr lvl="1"/>
             <a:r>
-              <a:rPr lang="en-US" smtClean="0"/>
+              <a:rPr lang="en-US"/>
               <a:t>Second level</a:t>
             </a:r>
           </a:p>
           <a:p>
             <a:pPr lvl="2"/>
             <a:r>
-              <a:rPr lang="en-US" smtClean="0"/>
+              <a:rPr lang="en-US"/>
               <a:t>Third level</a:t>
             </a:r>
           </a:p>
           <a:p>
             <a:pPr lvl="3"/>
             <a:r>
-              <a:rPr lang="en-US" smtClean="0"/>
+              <a:rPr lang="en-US"/>
               <a:t>Fourth level</a:t>
             </a:r>
           </a:p>
           <a:p>
             <a:pPr lvl="4"/>
             <a:r>
-              <a:rPr lang="en-US" smtClean="0"/>
+              <a:rPr lang="en-US"/>
               <a:t>Fifth level</a:t>
             </a:r>
-            <a:endParaRPr lang="en-US"/>
           </a:p>
         </p:txBody>
       </p:sp>
@@ -817,7 +825,7 @@
           <a:p>
             <a:fld id="{5BCAD085-E8A6-8845-BD4E-CB4CCA059FC4}" type="datetimeFigureOut">
               <a:rPr lang="en-US" smtClean="0"/>
-              <a:t>1/27/13</a:t>
+              <a:t>10/29/2026</a:t>
             </a:fld>
             <a:endParaRPr lang="en-US"/>
           </a:p>
@@ -920,10 +928,9 @@
           </a:lstStyle>
           <a:p>
             <a:r>
-              <a:rPr lang="en-US" smtClean="0"/>
+              <a:rPr lang="en-US"/>
               <a:t>Click to edit Master title style</a:t>
             </a:r>
-            <a:endParaRPr lang="en-US"/>
           </a:p>
         </p:txBody>
       </p:sp>
@@ -1040,7 +1047,7 @@
           <a:p>
             <a:pPr lvl="0"/>
             <a:r>
-              <a:rPr lang="en-US" smtClean="0"/>
+              <a:rPr lang="en-US"/>
               <a:t>Click to edit Master text styles</a:t>
             </a:r>
           </a:p>
@@ -1063,7 +1070,7 @@
           <a:p>
             <a:fld id="{5BCAD085-E8A6-8845-BD4E-CB4CCA059FC4}" type="datetimeFigureOut">
               <a:rPr lang="en-US" smtClean="0"/>
-              <a:t>1/27/13</a:t>
+              <a:t>10/29/2026</a:t>
             </a:fld>
             <a:endParaRPr lang="en-US"/>
           </a:p>
@@ -1157,10 +1164,9 @@
           <a:lstStyle/>
           <a:p>
             <a:r>
-              <a:rPr lang="en-US" smtClean="0"/>
+              <a:rPr lang="en-US"/>
               <a:t>Click to edit Master title style</a:t>
             </a:r>
-            <a:endParaRPr lang="en-US"/>
           </a:p>
         </p:txBody>
       </p:sp>
@@ -1214,38 +1220,37 @@
           <a:p>
             <a:pPr lvl="0"/>
             <a:r>
-              <a:rPr lang="en-US" smtClean="0"/>
+              <a:rPr lang="en-US"/>
               <a:t>Click to edit Master text styles</a:t>
             </a:r>
           </a:p>
           <a:p>
             <a:pPr lvl="1"/>
             <a:r>
-              <a:rPr lang="en-US" smtClean="0"/>
+              <a:rPr lang="en-US"/>
               <a:t>Second level</a:t>
             </a:r>
           </a:p>
           <a:p>
             <a:pPr lvl="2"/>
             <a:r>
-              <a:rPr lang="en-US" smtClean="0"/>
+              <a:rPr lang="en-US"/>
               <a:t>Third level</a:t>
             </a:r>
           </a:p>
           <a:p>
             <a:pPr lvl="3"/>
             <a:r>
-              <a:rPr lang="en-US" smtClean="0"/>
+              <a:rPr lang="en-US"/>
               <a:t>Fourth level</a:t>
             </a:r>
           </a:p>
           <a:p>
             <a:pPr lvl="4"/>
             <a:r>
-              <a:rPr lang="en-US" smtClean="0"/>
+              <a:rPr lang="en-US"/>
               <a:t>Fifth level</a:t>
             </a:r>
-            <a:endParaRPr lang="en-US"/>
           </a:p>
         </p:txBody>
       </p:sp>
@@ -1299,38 +1304,37 @@
           <a:p>
             <a:pPr lvl="0"/>
             <a:r>
-              <a:rPr lang="en-US" smtClean="0"/>
+              <a:rPr lang="en-US"/>
               <a:t>Click to edit Master text styles</a:t>
             </a:r>
           </a:p>
           <a:p>
             <a:pPr lvl="1"/>
             <a:r>
-              <a:rPr lang="en-US" smtClean="0"/>
+              <a:rPr lang="en-US"/>
               <a:t>Second level</a:t>
             </a:r>
           </a:p>
           <a:p>
             <a:pPr lvl="2"/>
             <a:r>
-              <a:rPr lang="en-US" smtClean="0"/>
+              <a:rPr lang="en-US"/>
               <a:t>Third level</a:t>
             </a:r>
           </a:p>
           <a:p>
             <a:pPr lvl="3"/>
             <a:r>
-              <a:rPr lang="en-US" smtClean="0"/>
+              <a:rPr lang="en-US"/>
               <a:t>Fourth level</a:t>
             </a:r>
           </a:p>
           <a:p>
             <a:pPr lvl="4"/>
             <a:r>
-              <a:rPr lang="en-US" smtClean="0"/>
+              <a:rPr lang="en-US"/>
               <a:t>Fifth level</a:t>
             </a:r>
-            <a:endParaRPr lang="en-US"/>
           </a:p>
         </p:txBody>
       </p:sp>
@@ -1351,7 +1355,7 @@
           <a:p>
             <a:fld id="{5BCAD085-E8A6-8845-BD4E-CB4CCA059FC4}" type="datetimeFigureOut">
               <a:rPr lang="en-US" smtClean="0"/>
-              <a:t>1/27/13</a:t>
+              <a:t>10/29/2026</a:t>
             </a:fld>
             <a:endParaRPr lang="en-US"/>
           </a:p>
@@ -1449,10 +1453,9 @@
           </a:lstStyle>
           <a:p>
             <a:r>
-              <a:rPr lang="en-US" smtClean="0"/>
+              <a:rPr lang="en-US"/>
               <a:t>Click to edit Master title style</a:t>
             </a:r>
-            <a:endParaRPr lang="en-US"/>
           </a:p>
         </p:txBody>
       </p:sp>
@@ -1515,7 +1518,7 @@
           <a:p>
             <a:pPr lvl="0"/>
             <a:r>
-              <a:rPr lang="en-US" smtClean="0"/>
+              <a:rPr lang="en-US"/>
               <a:t>Click to edit Master text styles</a:t>
             </a:r>
           </a:p>
@@ -1571,38 +1574,37 @@
           <a:p>
             <a:pPr lvl="0"/>
             <a:r>
-              <a:rPr lang="en-US" smtClean="0"/>
+              <a:rPr lang="en-US"/>
               <a:t>Click to edit Master text styles</a:t>
             </a:r>
           </a:p>
           <a:p>
             <a:pPr lvl="1"/>
             <a:r>
-              <a:rPr lang="en-US" smtClean="0"/>
+              <a:rPr lang="en-US"/>
               <a:t>Second level</a:t>
             </a:r>
           </a:p>
           <a:p>
             <a:pPr lvl="2"/>
             <a:r>
-              <a:rPr lang="en-US" smtClean="0"/>
+              <a:rPr lang="en-US"/>
               <a:t>Third level</a:t>
             </a:r>
           </a:p>
           <a:p>
             <a:pPr lvl="3"/>
             <a:r>
-              <a:rPr lang="en-US" smtClean="0"/>
+              <a:rPr lang="en-US"/>
               <a:t>Fourth level</a:t>
             </a:r>
           </a:p>
           <a:p>
             <a:pPr lvl="4"/>
             <a:r>
-              <a:rPr lang="en-US" smtClean="0"/>
+              <a:rPr lang="en-US"/>
               <a:t>Fifth level</a:t>
             </a:r>
-            <a:endParaRPr lang="en-US"/>
           </a:p>
         </p:txBody>
       </p:sp>
@@ -1665,7 +1667,7 @@
           <a:p>
             <a:pPr lvl="0"/>
             <a:r>
-              <a:rPr lang="en-US" smtClean="0"/>
+              <a:rPr lang="en-US"/>
               <a:t>Click to edit Master text styles</a:t>
             </a:r>
           </a:p>
@@ -1721,38 +1723,37 @@
           <a:p>
             <a:pPr lvl="0"/>
             <a:r>
-              <a:rPr lang="en-US" smtClean="0"/>
+              <a:rPr lang="en-US"/>
               <a:t>Click to edit Master text styles</a:t>
             </a:r>
           </a:p>
           <a:p>
             <a:pPr lvl="1"/>
             <a:r>
-              <a:rPr lang="en-US" smtClean="0"/>
+              <a:rPr lang="en-US"/>
               <a:t>Second level</a:t>
             </a:r>
           </a:p>
           <a:p>
             <a:pPr lvl="2"/>
             <a:r>
-              <a:rPr lang="en-US" smtClean="0"/>
+              <a:rPr lang="en-US"/>
               <a:t>Third level</a:t>
             </a:r>
           </a:p>
           <a:p>
             <a:pPr lvl="3"/>
             <a:r>
-              <a:rPr lang="en-US" smtClean="0"/>
+              <a:rPr lang="en-US"/>
               <a:t>Fourth level</a:t>
             </a:r>
           </a:p>
           <a:p>
             <a:pPr lvl="4"/>
             <a:r>
-              <a:rPr lang="en-US" smtClean="0"/>
+              <a:rPr lang="en-US"/>
               <a:t>Fifth level</a:t>
             </a:r>
-            <a:endParaRPr lang="en-US"/>
           </a:p>
         </p:txBody>
       </p:sp>
@@ -1773,7 +1774,7 @@
           <a:p>
             <a:fld id="{5BCAD085-E8A6-8845-BD4E-CB4CCA059FC4}" type="datetimeFigureOut">
               <a:rPr lang="en-US" smtClean="0"/>
-              <a:t>1/27/13</a:t>
+              <a:t>10/29/2026</a:t>
             </a:fld>
             <a:endParaRPr lang="en-US"/>
           </a:p>
@@ -1867,10 +1868,9 @@
           <a:lstStyle/>
           <a:p>
             <a:r>
-              <a:rPr lang="en-US" smtClean="0"/>
+              <a:rPr lang="en-US"/>
               <a:t>Click to edit Master title style</a:t>
             </a:r>
-            <a:endParaRPr lang="en-US"/>
           </a:p>
         </p:txBody>
       </p:sp>
@@ -1891,7 +1891,7 @@
           <a:p>
             <a:fld id="{5BCAD085-E8A6-8845-BD4E-CB4CCA059FC4}" type="datetimeFigureOut">
               <a:rPr lang="en-US" smtClean="0"/>
-              <a:t>1/27/13</a:t>
+              <a:t>10/29/2026</a:t>
             </a:fld>
             <a:endParaRPr lang="en-US"/>
           </a:p>
@@ -1986,7 +1986,7 @@
           <a:p>
             <a:fld id="{5BCAD085-E8A6-8845-BD4E-CB4CCA059FC4}" type="datetimeFigureOut">
               <a:rPr lang="en-US" smtClean="0"/>
-              <a:t>1/27/13</a:t>
+              <a:t>10/29/2026</a:t>
             </a:fld>
             <a:endParaRPr lang="en-US"/>
           </a:p>
@@ -2089,10 +2089,9 @@
           </a:lstStyle>
           <a:p>
             <a:r>
-              <a:rPr lang="en-US" smtClean="0"/>
+              <a:rPr lang="en-US"/>
               <a:t>Click to edit Master title style</a:t>
             </a:r>
-            <a:endParaRPr lang="en-US"/>
           </a:p>
         </p:txBody>
       </p:sp>
@@ -2146,38 +2145,37 @@
           <a:p>
             <a:pPr lvl="0"/>
             <a:r>
-              <a:rPr lang="en-US" smtClean="0"/>
+              <a:rPr lang="en-US"/>
               <a:t>Click to edit Master text styles</a:t>
             </a:r>
           </a:p>
           <a:p>
             <a:pPr lvl="1"/>
             <a:r>
-              <a:rPr lang="en-US" smtClean="0"/>
+              <a:rPr lang="en-US"/>
               <a:t>Second level</a:t>
             </a:r>
           </a:p>
           <a:p>
             <a:pPr lvl="2"/>
             <a:r>
-              <a:rPr lang="en-US" smtClean="0"/>
+              <a:rPr lang="en-US"/>
               <a:t>Third level</a:t>
             </a:r>
           </a:p>
           <a:p>
             <a:pPr lvl="3"/>
             <a:r>
-              <a:rPr lang="en-US" smtClean="0"/>
+              <a:rPr lang="en-US"/>
               <a:t>Fourth level</a:t>
             </a:r>
           </a:p>
           <a:p>
             <a:pPr lvl="4"/>
             <a:r>
-              <a:rPr lang="en-US" smtClean="0"/>
+              <a:rPr lang="en-US"/>
               <a:t>Fifth level</a:t>
             </a:r>
-            <a:endParaRPr lang="en-US"/>
           </a:p>
         </p:txBody>
       </p:sp>
@@ -2240,7 +2238,7 @@
           <a:p>
             <a:pPr lvl="0"/>
             <a:r>
-              <a:rPr lang="en-US" smtClean="0"/>
+              <a:rPr lang="en-US"/>
               <a:t>Click to edit Master text styles</a:t>
             </a:r>
           </a:p>
@@ -2263,7 +2261,7 @@
           <a:p>
             <a:fld id="{5BCAD085-E8A6-8845-BD4E-CB4CCA059FC4}" type="datetimeFigureOut">
               <a:rPr lang="en-US" smtClean="0"/>
-              <a:t>1/27/13</a:t>
+              <a:t>10/29/2026</a:t>
             </a:fld>
             <a:endParaRPr lang="en-US"/>
           </a:p>
@@ -2366,10 +2364,9 @@
           </a:lstStyle>
           <a:p>
             <a:r>
-              <a:rPr lang="en-US" smtClean="0"/>
+              <a:rPr lang="en-US"/>
               <a:t>Click to edit Master title style</a:t>
             </a:r>
-            <a:endParaRPr lang="en-US"/>
           </a:p>
         </p:txBody>
       </p:sp>
@@ -2493,7 +2490,7 @@
           <a:p>
             <a:pPr lvl="0"/>
             <a:r>
-              <a:rPr lang="en-US" smtClean="0"/>
+              <a:rPr lang="en-US"/>
               <a:t>Click to edit Master text styles</a:t>
             </a:r>
           </a:p>
@@ -2516,7 +2513,7 @@
           <a:p>
             <a:fld id="{5BCAD085-E8A6-8845-BD4E-CB4CCA059FC4}" type="datetimeFigureOut">
               <a:rPr lang="en-US" smtClean="0"/>
-              <a:t>1/27/13</a:t>
+              <a:t>10/29/2026</a:t>
             </a:fld>
             <a:endParaRPr lang="en-US"/>
           </a:p>
@@ -2625,10 +2622,9 @@
           <a:lstStyle/>
           <a:p>
             <a:r>
-              <a:rPr lang="en-US" smtClean="0"/>
+              <a:rPr lang="en-US"/>
               <a:t>Click to edit Master title style</a:t>
             </a:r>
-            <a:endParaRPr lang="en-US"/>
           </a:p>
         </p:txBody>
       </p:sp>
@@ -2659,38 +2655,37 @@
           <a:p>
             <a:pPr lvl="0"/>
             <a:r>
-              <a:rPr lang="en-US" smtClean="0"/>
+              <a:rPr lang="en-US"/>
               <a:t>Click to edit Master text styles</a:t>
             </a:r>
           </a:p>
           <a:p>
             <a:pPr lvl="1"/>
             <a:r>
-              <a:rPr lang="en-US" smtClean="0"/>
+              <a:rPr lang="en-US"/>
               <a:t>Second level</a:t>
             </a:r>
           </a:p>
           <a:p>
             <a:pPr lvl="2"/>
             <a:r>
-              <a:rPr lang="en-US" smtClean="0"/>
+              <a:rPr lang="en-US"/>
               <a:t>Third level</a:t>
             </a:r>
           </a:p>
           <a:p>
             <a:pPr lvl="3"/>
             <a:r>
-              <a:rPr lang="en-US" smtClean="0"/>
+              <a:rPr lang="en-US"/>
               <a:t>Fourth level</a:t>
             </a:r>
           </a:p>
           <a:p>
             <a:pPr lvl="4"/>
             <a:r>
-              <a:rPr lang="en-US" smtClean="0"/>
+              <a:rPr lang="en-US"/>
               <a:t>Fifth level</a:t>
             </a:r>
-            <a:endParaRPr lang="en-US"/>
           </a:p>
         </p:txBody>
       </p:sp>
@@ -2729,7 +2724,7 @@
           <a:p>
             <a:fld id="{5BCAD085-E8A6-8845-BD4E-CB4CCA059FC4}" type="datetimeFigureOut">
               <a:rPr lang="en-US" smtClean="0"/>
-              <a:t>1/27/13</a:t>
+              <a:t>10/29/2026</a:t>
             </a:fld>
             <a:endParaRPr lang="en-US"/>
           </a:p>
@@ -3088,7 +3083,7 @@
 </file>
 
 <file path=ppt/slides/slide1.xml><?xml version="1.0" encoding="utf-8"?>
-<p:sld xmlns:a="http://schemas.openxmlformats.org/drawingml/2006/main" xmlns:p="http://schemas.openxmlformats.org/presentationml/2006/main" xmlns:r="http://schemas.openxmlformats.org/officeDocument/2006/relationships">
+<p:sld xmlns:a="http://schemas.openxmlformats.org/drawingml/2006/main" xmlns:r="http://schemas.openxmlformats.org/officeDocument/2006/relationships" xmlns:p="http://schemas.openxmlformats.org/presentationml/2006/main">
   <p:cSld>
     <p:bg>
       <p:bgPr>
@@ -3104,7 +3099,14 @@
         <p:cNvGrpSpPr/>
         <p:nvPr/>
       </p:nvGrpSpPr>
-      <p:grpSpPr/>
+      <p:grpSpPr>
+        <a:xfrm>
+          <a:off x="0" y="0"/>
+          <a:ext cx="0" cy="0"/>
+          <a:chOff x="0" y="0"/>
+          <a:chExt cx="0" cy="0"/>
+        </a:xfrm>
+      </p:grpSpPr>
       <p:sp>
         <p:nvSpPr>
           <p:cNvPr id="2" name="Rectangle 1"/>
@@ -3145,6 +3147,7 @@
           <a:lstStyle/>
           <a:p>
             <a:pPr algn="ctr"/>
+            <a:endParaRPr/>
           </a:p>
         </p:txBody>
       </p:sp>
@@ -3256,6 +3259,7 @@
           <a:lstStyle/>
           <a:p>
             <a:pPr algn="ctr"/>
+            <a:endParaRPr/>
           </a:p>
         </p:txBody>
       </p:sp>
@@ -3337,6 +3341,7 @@
           <a:lstStyle/>
           <a:p>
             <a:pPr algn="ctr"/>
+            <a:endParaRPr/>
           </a:p>
         </p:txBody>
       </p:sp>
@@ -3450,6 +3455,7 @@
           <a:lstStyle/>
           <a:p>
             <a:pPr algn="ctr"/>
+            <a:endParaRPr/>
           </a:p>
         </p:txBody>
       </p:sp>
@@ -3563,6 +3569,7 @@
           <a:lstStyle/>
           <a:p>
             <a:pPr algn="ctr"/>
+            <a:endParaRPr/>
           </a:p>
         </p:txBody>
       </p:sp>
@@ -3676,6 +3683,7 @@
           <a:lstStyle/>
           <a:p>
             <a:pPr algn="ctr"/>
+            <a:endParaRPr/>
           </a:p>
         </p:txBody>
       </p:sp>
@@ -3821,6 +3829,7 @@
           <a:lstStyle/>
           <a:p>
             <a:pPr algn="ctr"/>
+            <a:endParaRPr/>
           </a:p>
         </p:txBody>
       </p:sp>
@@ -3898,6 +3907,7 @@
           <a:lstStyle/>
           <a:p>
             <a:pPr algn="ctr"/>
+            <a:endParaRPr/>
           </a:p>
         </p:txBody>
       </p:sp>
@@ -3975,6 +3985,7 @@
           <a:lstStyle/>
           <a:p>
             <a:pPr algn="ctr"/>
+            <a:endParaRPr/>
           </a:p>
         </p:txBody>
       </p:sp>
@@ -4021,7 +4032,7 @@
 </file>
 
 <file path=ppt/slides/slide10.xml><?xml version="1.0" encoding="utf-8"?>
-<p:sld xmlns:a="http://schemas.openxmlformats.org/drawingml/2006/main" xmlns:p="http://schemas.openxmlformats.org/presentationml/2006/main" xmlns:r="http://schemas.openxmlformats.org/officeDocument/2006/relationships">
+<p:sld xmlns:a="http://schemas.openxmlformats.org/drawingml/2006/main" xmlns:r="http://schemas.openxmlformats.org/officeDocument/2006/relationships" xmlns:p="http://schemas.openxmlformats.org/presentationml/2006/main">
   <p:cSld>
     <p:bg>
       <p:bgPr>
@@ -4037,7 +4048,14 @@
         <p:cNvGrpSpPr/>
         <p:nvPr/>
       </p:nvGrpSpPr>
-      <p:grpSpPr/>
+      <p:grpSpPr>
+        <a:xfrm>
+          <a:off x="0" y="0"/>
+          <a:ext cx="0" cy="0"/>
+          <a:chOff x="0" y="0"/>
+          <a:chExt cx="0" cy="0"/>
+        </a:xfrm>
+      </p:grpSpPr>
       <p:sp>
         <p:nvSpPr>
           <p:cNvPr id="2" name="TextBox 1"/>
@@ -4146,6 +4164,7 @@
           <a:lstStyle/>
           <a:p>
             <a:pPr algn="ctr"/>
+            <a:endParaRPr/>
           </a:p>
         </p:txBody>
       </p:sp>
@@ -4191,6 +4210,7 @@
           <a:lstStyle/>
           <a:p>
             <a:pPr algn="ctr"/>
+            <a:endParaRPr/>
           </a:p>
         </p:txBody>
       </p:sp>
@@ -4406,6 +4426,7 @@
           <a:lstStyle/>
           <a:p>
             <a:pPr algn="ctr"/>
+            <a:endParaRPr/>
           </a:p>
         </p:txBody>
       </p:sp>
@@ -4621,6 +4642,7 @@
           <a:lstStyle/>
           <a:p>
             <a:pPr algn="ctr"/>
+            <a:endParaRPr/>
           </a:p>
         </p:txBody>
       </p:sp>
@@ -4836,6 +4858,7 @@
           <a:lstStyle/>
           <a:p>
             <a:pPr algn="ctr"/>
+            <a:endParaRPr/>
           </a:p>
         </p:txBody>
       </p:sp>
@@ -5051,6 +5074,7 @@
           <a:lstStyle/>
           <a:p>
             <a:pPr algn="ctr"/>
+            <a:endParaRPr/>
           </a:p>
         </p:txBody>
       </p:sp>
@@ -5266,6 +5290,7 @@
           <a:lstStyle/>
           <a:p>
             <a:pPr algn="ctr"/>
+            <a:endParaRPr/>
           </a:p>
         </p:txBody>
       </p:sp>
@@ -5481,6 +5506,7 @@
           <a:lstStyle/>
           <a:p>
             <a:pPr algn="ctr"/>
+            <a:endParaRPr/>
           </a:p>
         </p:txBody>
       </p:sp>
@@ -5832,6 +5858,7 @@
           <a:lstStyle/>
           <a:p>
             <a:pPr algn="ctr"/>
+            <a:endParaRPr/>
           </a:p>
         </p:txBody>
       </p:sp>
@@ -5878,7 +5905,7 @@
 </file>
 
 <file path=ppt/slides/slide2.xml><?xml version="1.0" encoding="utf-8"?>
-<p:sld xmlns:a="http://schemas.openxmlformats.org/drawingml/2006/main" xmlns:p="http://schemas.openxmlformats.org/presentationml/2006/main" xmlns:r="http://schemas.openxmlformats.org/officeDocument/2006/relationships">
+<p:sld xmlns:a="http://schemas.openxmlformats.org/drawingml/2006/main" xmlns:r="http://schemas.openxmlformats.org/officeDocument/2006/relationships" xmlns:p="http://schemas.openxmlformats.org/presentationml/2006/main">
   <p:cSld>
     <p:bg>
       <p:bgPr>
@@ -5894,7 +5921,14 @@
         <p:cNvGrpSpPr/>
         <p:nvPr/>
       </p:nvGrpSpPr>
-      <p:grpSpPr/>
+      <p:grpSpPr>
+        <a:xfrm>
+          <a:off x="0" y="0"/>
+          <a:ext cx="0" cy="0"/>
+          <a:chOff x="0" y="0"/>
+          <a:chExt cx="0" cy="0"/>
+        </a:xfrm>
+      </p:grpSpPr>
       <p:sp>
         <p:nvSpPr>
           <p:cNvPr id="2" name="TextBox 1"/>
@@ -6003,6 +6037,7 @@
           <a:lstStyle/>
           <a:p>
             <a:pPr algn="ctr"/>
+            <a:endParaRPr/>
           </a:p>
         </p:txBody>
       </p:sp>
@@ -6048,6 +6083,7 @@
           <a:lstStyle/>
           <a:p>
             <a:pPr algn="ctr"/>
+            <a:endParaRPr/>
           </a:p>
         </p:txBody>
       </p:sp>
@@ -6125,6 +6161,7 @@
           <a:lstStyle/>
           <a:p>
             <a:pPr algn="ctr"/>
+            <a:endParaRPr/>
           </a:p>
         </p:txBody>
       </p:sp>
@@ -6207,6 +6244,7 @@
           <a:lstStyle/>
           <a:p>
             <a:pPr algn="ctr"/>
+            <a:endParaRPr/>
           </a:p>
         </p:txBody>
       </p:sp>
@@ -6284,6 +6322,7 @@
           <a:lstStyle/>
           <a:p>
             <a:pPr algn="ctr"/>
+            <a:endParaRPr/>
           </a:p>
         </p:txBody>
       </p:sp>
@@ -6366,6 +6405,7 @@
           <a:lstStyle/>
           <a:p>
             <a:pPr algn="ctr"/>
+            <a:endParaRPr/>
           </a:p>
         </p:txBody>
       </p:sp>
@@ -6443,6 +6483,7 @@
           <a:lstStyle/>
           <a:p>
             <a:pPr algn="ctr"/>
+            <a:endParaRPr/>
           </a:p>
         </p:txBody>
       </p:sp>
@@ -6525,6 +6566,7 @@
           <a:lstStyle/>
           <a:p>
             <a:pPr algn="ctr"/>
+            <a:endParaRPr/>
           </a:p>
         </p:txBody>
       </p:sp>
@@ -6571,7 +6613,7 @@
 </file>
 
 <file path=ppt/slides/slide3.xml><?xml version="1.0" encoding="utf-8"?>
-<p:sld xmlns:a="http://schemas.openxmlformats.org/drawingml/2006/main" xmlns:p="http://schemas.openxmlformats.org/presentationml/2006/main" xmlns:r="http://schemas.openxmlformats.org/officeDocument/2006/relationships">
+<p:sld xmlns:a="http://schemas.openxmlformats.org/drawingml/2006/main" xmlns:r="http://schemas.openxmlformats.org/officeDocument/2006/relationships" xmlns:p="http://schemas.openxmlformats.org/presentationml/2006/main">
   <p:cSld>
     <p:bg>
       <p:bgPr>
@@ -6587,7 +6629,14 @@
         <p:cNvGrpSpPr/>
         <p:nvPr/>
       </p:nvGrpSpPr>
-      <p:grpSpPr/>
+      <p:grpSpPr>
+        <a:xfrm>
+          <a:off x="0" y="0"/>
+          <a:ext cx="0" cy="0"/>
+          <a:chOff x="0" y="0"/>
+          <a:chExt cx="0" cy="0"/>
+        </a:xfrm>
+      </p:grpSpPr>
       <p:sp>
         <p:nvSpPr>
           <p:cNvPr id="2" name="TextBox 1"/>
@@ -6696,6 +6745,7 @@
           <a:lstStyle/>
           <a:p>
             <a:pPr algn="ctr"/>
+            <a:endParaRPr/>
           </a:p>
         </p:txBody>
       </p:sp>
@@ -6741,6 +6791,7 @@
           <a:lstStyle/>
           <a:p>
             <a:pPr algn="ctr"/>
+            <a:endParaRPr/>
           </a:p>
         </p:txBody>
       </p:sp>
@@ -6818,6 +6869,7 @@
           <a:lstStyle/>
           <a:p>
             <a:pPr algn="ctr"/>
+            <a:endParaRPr/>
           </a:p>
         </p:txBody>
       </p:sp>
@@ -6933,6 +6985,7 @@
           <a:lstStyle/>
           <a:p>
             <a:pPr algn="ctr"/>
+            <a:endParaRPr/>
           </a:p>
         </p:txBody>
       </p:sp>
@@ -7010,6 +7063,7 @@
           <a:lstStyle/>
           <a:p>
             <a:pPr algn="ctr"/>
+            <a:endParaRPr/>
           </a:p>
         </p:txBody>
       </p:sp>
@@ -7125,6 +7179,7 @@
           <a:lstStyle/>
           <a:p>
             <a:pPr algn="ctr"/>
+            <a:endParaRPr/>
           </a:p>
         </p:txBody>
       </p:sp>
@@ -7202,6 +7257,7 @@
           <a:lstStyle/>
           <a:p>
             <a:pPr algn="ctr"/>
+            <a:endParaRPr/>
           </a:p>
         </p:txBody>
       </p:sp>
@@ -7317,6 +7373,7 @@
           <a:lstStyle/>
           <a:p>
             <a:pPr algn="ctr"/>
+            <a:endParaRPr/>
           </a:p>
         </p:txBody>
       </p:sp>
@@ -7394,6 +7451,7 @@
           <a:lstStyle/>
           <a:p>
             <a:pPr algn="ctr"/>
+            <a:endParaRPr/>
           </a:p>
         </p:txBody>
       </p:sp>
@@ -7509,6 +7567,7 @@
           <a:lstStyle/>
           <a:p>
             <a:pPr algn="ctr"/>
+            <a:endParaRPr/>
           </a:p>
         </p:txBody>
       </p:sp>
@@ -7586,6 +7645,7 @@
           <a:lstStyle/>
           <a:p>
             <a:pPr algn="ctr"/>
+            <a:endParaRPr/>
           </a:p>
         </p:txBody>
       </p:sp>
@@ -7667,6 +7727,7 @@
           <a:lstStyle/>
           <a:p>
             <a:pPr algn="ctr"/>
+            <a:endParaRPr/>
           </a:p>
         </p:txBody>
       </p:sp>
@@ -7781,6 +7842,7 @@
           <a:lstStyle/>
           <a:p>
             <a:pPr algn="ctr"/>
+            <a:endParaRPr/>
           </a:p>
         </p:txBody>
       </p:sp>
@@ -7895,6 +7957,7 @@
           <a:lstStyle/>
           <a:p>
             <a:pPr algn="ctr"/>
+            <a:endParaRPr/>
           </a:p>
         </p:txBody>
       </p:sp>
@@ -8009,6 +8072,7 @@
           <a:lstStyle/>
           <a:p>
             <a:pPr algn="ctr"/>
+            <a:endParaRPr/>
           </a:p>
         </p:txBody>
       </p:sp>
@@ -8090,7 +8154,7 @@
 </file>
 
 <file path=ppt/slides/slide4.xml><?xml version="1.0" encoding="utf-8"?>
-<p:sld xmlns:a="http://schemas.openxmlformats.org/drawingml/2006/main" xmlns:p="http://schemas.openxmlformats.org/presentationml/2006/main" xmlns:r="http://schemas.openxmlformats.org/officeDocument/2006/relationships">
+<p:sld xmlns:a="http://schemas.openxmlformats.org/drawingml/2006/main" xmlns:r="http://schemas.openxmlformats.org/officeDocument/2006/relationships" xmlns:p="http://schemas.openxmlformats.org/presentationml/2006/main">
   <p:cSld>
     <p:bg>
       <p:bgPr>
@@ -8106,7 +8170,14 @@
         <p:cNvGrpSpPr/>
         <p:nvPr/>
       </p:nvGrpSpPr>
-      <p:grpSpPr/>
+      <p:grpSpPr>
+        <a:xfrm>
+          <a:off x="0" y="0"/>
+          <a:ext cx="0" cy="0"/>
+          <a:chOff x="0" y="0"/>
+          <a:chExt cx="0" cy="0"/>
+        </a:xfrm>
+      </p:grpSpPr>
       <p:sp>
         <p:nvSpPr>
           <p:cNvPr id="2" name="TextBox 1"/>
@@ -8215,6 +8286,7 @@
           <a:lstStyle/>
           <a:p>
             <a:pPr algn="ctr"/>
+            <a:endParaRPr/>
           </a:p>
         </p:txBody>
       </p:sp>
@@ -8260,6 +8332,7 @@
           <a:lstStyle/>
           <a:p>
             <a:pPr algn="ctr"/>
+            <a:endParaRPr/>
           </a:p>
         </p:txBody>
       </p:sp>
@@ -8303,6 +8376,7 @@
           <a:lstStyle/>
           <a:p>
             <a:pPr algn="ctr"/>
+            <a:endParaRPr/>
           </a:p>
         </p:txBody>
       </p:sp>
@@ -8415,6 +8489,7 @@
           <a:lstStyle/>
           <a:p>
             <a:pPr algn="ctr"/>
+            <a:endParaRPr/>
           </a:p>
         </p:txBody>
       </p:sp>
@@ -8499,6 +8574,7 @@
           <a:lstStyle/>
           <a:p>
             <a:pPr algn="ctr"/>
+            <a:endParaRPr/>
           </a:p>
         </p:txBody>
       </p:sp>
@@ -8542,6 +8618,7 @@
           <a:lstStyle/>
           <a:p>
             <a:pPr algn="ctr"/>
+            <a:endParaRPr/>
           </a:p>
         </p:txBody>
       </p:sp>
@@ -8654,6 +8731,7 @@
           <a:lstStyle/>
           <a:p>
             <a:pPr algn="ctr"/>
+            <a:endParaRPr/>
           </a:p>
         </p:txBody>
       </p:sp>
@@ -8737,6 +8815,7 @@
           <a:lstStyle/>
           <a:p>
             <a:pPr algn="ctr"/>
+            <a:endParaRPr/>
           </a:p>
         </p:txBody>
       </p:sp>
@@ -8780,6 +8859,7 @@
           <a:lstStyle/>
           <a:p>
             <a:pPr algn="ctr"/>
+            <a:endParaRPr/>
           </a:p>
         </p:txBody>
       </p:sp>
@@ -8892,6 +8972,7 @@
           <a:lstStyle/>
           <a:p>
             <a:pPr algn="ctr"/>
+            <a:endParaRPr/>
           </a:p>
         </p:txBody>
       </p:sp>
@@ -8976,6 +9057,7 @@
           <a:lstStyle/>
           <a:p>
             <a:pPr algn="ctr"/>
+            <a:endParaRPr/>
           </a:p>
         </p:txBody>
       </p:sp>
@@ -9019,6 +9101,7 @@
           <a:lstStyle/>
           <a:p>
             <a:pPr algn="ctr"/>
+            <a:endParaRPr/>
           </a:p>
         </p:txBody>
       </p:sp>
@@ -9131,6 +9214,7 @@
           <a:lstStyle/>
           <a:p>
             <a:pPr algn="ctr"/>
+            <a:endParaRPr/>
           </a:p>
         </p:txBody>
       </p:sp>
@@ -9214,6 +9298,7 @@
           <a:lstStyle/>
           <a:p>
             <a:pPr algn="ctr"/>
+            <a:endParaRPr/>
           </a:p>
         </p:txBody>
       </p:sp>
@@ -9257,6 +9342,7 @@
           <a:lstStyle/>
           <a:p>
             <a:pPr algn="ctr"/>
+            <a:endParaRPr/>
           </a:p>
         </p:txBody>
       </p:sp>
@@ -9369,6 +9455,7 @@
           <a:lstStyle/>
           <a:p>
             <a:pPr algn="ctr"/>
+            <a:endParaRPr/>
           </a:p>
         </p:txBody>
       </p:sp>
@@ -9453,6 +9540,7 @@
           <a:lstStyle/>
           <a:p>
             <a:pPr algn="ctr"/>
+            <a:endParaRPr/>
           </a:p>
         </p:txBody>
       </p:sp>
@@ -9534,7 +9622,7 @@
 </file>
 
 <file path=ppt/slides/slide5.xml><?xml version="1.0" encoding="utf-8"?>
-<p:sld xmlns:a="http://schemas.openxmlformats.org/drawingml/2006/main" xmlns:p="http://schemas.openxmlformats.org/presentationml/2006/main" xmlns:r="http://schemas.openxmlformats.org/officeDocument/2006/relationships">
+<p:sld xmlns:a="http://schemas.openxmlformats.org/drawingml/2006/main" xmlns:r="http://schemas.openxmlformats.org/officeDocument/2006/relationships" xmlns:p="http://schemas.openxmlformats.org/presentationml/2006/main">
   <p:cSld>
     <p:bg>
       <p:bgPr>
@@ -9550,7 +9638,14 @@
         <p:cNvGrpSpPr/>
         <p:nvPr/>
       </p:nvGrpSpPr>
-      <p:grpSpPr/>
+      <p:grpSpPr>
+        <a:xfrm>
+          <a:off x="0" y="0"/>
+          <a:ext cx="0" cy="0"/>
+          <a:chOff x="0" y="0"/>
+          <a:chExt cx="0" cy="0"/>
+        </a:xfrm>
+      </p:grpSpPr>
       <p:sp>
         <p:nvSpPr>
           <p:cNvPr id="2" name="TextBox 1"/>
@@ -9659,6 +9754,7 @@
           <a:lstStyle/>
           <a:p>
             <a:pPr algn="ctr"/>
+            <a:endParaRPr/>
           </a:p>
         </p:txBody>
       </p:sp>
@@ -9704,6 +9800,7 @@
           <a:lstStyle/>
           <a:p>
             <a:pPr algn="ctr"/>
+            <a:endParaRPr/>
           </a:p>
         </p:txBody>
       </p:sp>
@@ -9781,6 +9878,7 @@
           <a:lstStyle/>
           <a:p>
             <a:pPr algn="ctr"/>
+            <a:endParaRPr/>
           </a:p>
         </p:txBody>
       </p:sp>
@@ -9864,6 +9962,7 @@
           <a:lstStyle/>
           <a:p>
             <a:pPr algn="ctr"/>
+            <a:endParaRPr/>
           </a:p>
         </p:txBody>
       </p:sp>
@@ -9941,6 +10040,7 @@
           <a:lstStyle/>
           <a:p>
             <a:pPr algn="ctr"/>
+            <a:endParaRPr/>
           </a:p>
         </p:txBody>
       </p:sp>
@@ -10018,6 +10118,7 @@
           <a:lstStyle/>
           <a:p>
             <a:pPr algn="ctr"/>
+            <a:endParaRPr/>
           </a:p>
         </p:txBody>
       </p:sp>
@@ -10097,6 +10198,7 @@
           <a:lstStyle/>
           <a:p>
             <a:pPr algn="ctr"/>
+            <a:endParaRPr/>
           </a:p>
         </p:txBody>
       </p:sp>
@@ -10174,6 +10276,7 @@
           <a:lstStyle/>
           <a:p>
             <a:pPr algn="ctr"/>
+            <a:endParaRPr/>
           </a:p>
         </p:txBody>
       </p:sp>
@@ -10256,6 +10359,7 @@
           <a:lstStyle/>
           <a:p>
             <a:pPr algn="ctr"/>
+            <a:endParaRPr/>
           </a:p>
         </p:txBody>
       </p:sp>
@@ -10333,6 +10437,7 @@
           <a:lstStyle/>
           <a:p>
             <a:pPr algn="ctr"/>
+            <a:endParaRPr/>
           </a:p>
         </p:txBody>
       </p:sp>
@@ -10410,6 +10515,7 @@
           <a:lstStyle/>
           <a:p>
             <a:pPr algn="ctr"/>
+            <a:endParaRPr/>
           </a:p>
         </p:txBody>
       </p:sp>
@@ -10489,6 +10595,7 @@
           <a:lstStyle/>
           <a:p>
             <a:pPr algn="ctr"/>
+            <a:endParaRPr/>
           </a:p>
         </p:txBody>
       </p:sp>
@@ -10567,6 +10674,7 @@
           <a:lstStyle/>
           <a:p>
             <a:pPr algn="ctr"/>
+            <a:endParaRPr/>
           </a:p>
         </p:txBody>
       </p:sp>
@@ -10649,6 +10757,7 @@
           <a:lstStyle/>
           <a:p>
             <a:pPr algn="ctr"/>
+            <a:endParaRPr/>
           </a:p>
         </p:txBody>
       </p:sp>
@@ -10726,6 +10835,7 @@
           <a:lstStyle/>
           <a:p>
             <a:pPr algn="ctr"/>
+            <a:endParaRPr/>
           </a:p>
         </p:txBody>
       </p:sp>
@@ -10803,6 +10913,7 @@
           <a:lstStyle/>
           <a:p>
             <a:pPr algn="ctr"/>
+            <a:endParaRPr/>
           </a:p>
         </p:txBody>
       </p:sp>
@@ -10882,6 +10993,7 @@
           <a:lstStyle/>
           <a:p>
             <a:pPr algn="ctr"/>
+            <a:endParaRPr/>
           </a:p>
         </p:txBody>
       </p:sp>
@@ -11336,7 +11448,7 @@
 </file>
 
 <file path=ppt/slides/slide6.xml><?xml version="1.0" encoding="utf-8"?>
-<p:sld xmlns:a="http://schemas.openxmlformats.org/drawingml/2006/main" xmlns:p="http://schemas.openxmlformats.org/presentationml/2006/main" xmlns:r="http://schemas.openxmlformats.org/officeDocument/2006/relationships">
+<p:sld xmlns:a="http://schemas.openxmlformats.org/drawingml/2006/main" xmlns:r="http://schemas.openxmlformats.org/officeDocument/2006/relationships" xmlns:p="http://schemas.openxmlformats.org/presentationml/2006/main">
   <p:cSld>
     <p:bg>
       <p:bgPr>
@@ -11352,7 +11464,14 @@
         <p:cNvGrpSpPr/>
         <p:nvPr/>
       </p:nvGrpSpPr>
-      <p:grpSpPr/>
+      <p:grpSpPr>
+        <a:xfrm>
+          <a:off x="0" y="0"/>
+          <a:ext cx="0" cy="0"/>
+          <a:chOff x="0" y="0"/>
+          <a:chExt cx="0" cy="0"/>
+        </a:xfrm>
+      </p:grpSpPr>
       <p:sp>
         <p:nvSpPr>
           <p:cNvPr id="2" name="TextBox 1"/>
@@ -11461,6 +11580,7 @@
           <a:lstStyle/>
           <a:p>
             <a:pPr algn="ctr"/>
+            <a:endParaRPr/>
           </a:p>
         </p:txBody>
       </p:sp>
@@ -11506,6 +11626,7 @@
           <a:lstStyle/>
           <a:p>
             <a:pPr algn="ctr"/>
+            <a:endParaRPr/>
           </a:p>
         </p:txBody>
       </p:sp>
@@ -11585,6 +11706,7 @@
           <a:lstStyle/>
           <a:p>
             <a:pPr algn="ctr"/>
+            <a:endParaRPr/>
           </a:p>
         </p:txBody>
       </p:sp>
@@ -11702,6 +11824,7 @@
           <a:lstStyle/>
           <a:p>
             <a:pPr algn="ctr"/>
+            <a:endParaRPr/>
           </a:p>
         </p:txBody>
       </p:sp>
@@ -11781,6 +11904,7 @@
           <a:lstStyle/>
           <a:p>
             <a:pPr algn="ctr"/>
+            <a:endParaRPr/>
           </a:p>
         </p:txBody>
       </p:sp>
@@ -11898,6 +12022,7 @@
           <a:lstStyle/>
           <a:p>
             <a:pPr algn="ctr"/>
+            <a:endParaRPr/>
           </a:p>
         </p:txBody>
       </p:sp>
@@ -11977,6 +12102,7 @@
           <a:lstStyle/>
           <a:p>
             <a:pPr algn="ctr"/>
+            <a:endParaRPr/>
           </a:p>
         </p:txBody>
       </p:sp>
@@ -12094,6 +12220,7 @@
           <a:lstStyle/>
           <a:p>
             <a:pPr algn="ctr"/>
+            <a:endParaRPr/>
           </a:p>
         </p:txBody>
       </p:sp>
@@ -12176,7 +12303,7 @@
 </file>
 
 <file path=ppt/slides/slide7.xml><?xml version="1.0" encoding="utf-8"?>
-<p:sld xmlns:a="http://schemas.openxmlformats.org/drawingml/2006/main" xmlns:p="http://schemas.openxmlformats.org/presentationml/2006/main" xmlns:r="http://schemas.openxmlformats.org/officeDocument/2006/relationships">
+<p:sld xmlns:a="http://schemas.openxmlformats.org/drawingml/2006/main" xmlns:r="http://schemas.openxmlformats.org/officeDocument/2006/relationships" xmlns:p="http://schemas.openxmlformats.org/presentationml/2006/main">
   <p:cSld>
     <p:bg>
       <p:bgPr>
@@ -12192,7 +12319,14 @@
         <p:cNvGrpSpPr/>
         <p:nvPr/>
       </p:nvGrpSpPr>
-      <p:grpSpPr/>
+      <p:grpSpPr>
+        <a:xfrm>
+          <a:off x="0" y="0"/>
+          <a:ext cx="0" cy="0"/>
+          <a:chOff x="0" y="0"/>
+          <a:chExt cx="0" cy="0"/>
+        </a:xfrm>
+      </p:grpSpPr>
       <p:sp>
         <p:nvSpPr>
           <p:cNvPr id="2" name="TextBox 1"/>
@@ -12301,6 +12435,7 @@
           <a:lstStyle/>
           <a:p>
             <a:pPr algn="ctr"/>
+            <a:endParaRPr/>
           </a:p>
         </p:txBody>
       </p:sp>
@@ -12346,6 +12481,7 @@
           <a:lstStyle/>
           <a:p>
             <a:pPr algn="ctr"/>
+            <a:endParaRPr/>
           </a:p>
         </p:txBody>
       </p:sp>
@@ -12457,6 +12593,7 @@
           <a:lstStyle/>
           <a:p>
             <a:pPr algn="ctr"/>
+            <a:endParaRPr/>
           </a:p>
         </p:txBody>
       </p:sp>
@@ -12570,6 +12707,7 @@
           <a:lstStyle/>
           <a:p>
             <a:pPr algn="ctr"/>
+            <a:endParaRPr/>
           </a:p>
         </p:txBody>
       </p:sp>
@@ -12717,6 +12855,7 @@
           <a:lstStyle/>
           <a:p>
             <a:pPr algn="ctr"/>
+            <a:endParaRPr/>
           </a:p>
         </p:txBody>
       </p:sp>
@@ -12864,6 +13003,7 @@
           <a:lstStyle/>
           <a:p>
             <a:pPr algn="ctr"/>
+            <a:endParaRPr/>
           </a:p>
         </p:txBody>
       </p:sp>
@@ -13011,6 +13151,7 @@
           <a:lstStyle/>
           <a:p>
             <a:pPr algn="ctr"/>
+            <a:endParaRPr/>
           </a:p>
         </p:txBody>
       </p:sp>
@@ -13158,6 +13299,7 @@
           <a:lstStyle/>
           <a:p>
             <a:pPr algn="ctr"/>
+            <a:endParaRPr/>
           </a:p>
         </p:txBody>
       </p:sp>
@@ -13305,6 +13447,7 @@
           <a:lstStyle/>
           <a:p>
             <a:pPr algn="ctr"/>
+            <a:endParaRPr/>
           </a:p>
         </p:txBody>
       </p:sp>
@@ -13382,6 +13525,7 @@
           <a:lstStyle/>
           <a:p>
             <a:pPr algn="ctr"/>
+            <a:endParaRPr/>
           </a:p>
         </p:txBody>
       </p:sp>
@@ -13464,6 +13608,7 @@
           <a:lstStyle/>
           <a:p>
             <a:pPr algn="ctr"/>
+            <a:endParaRPr/>
           </a:p>
         </p:txBody>
       </p:sp>
@@ -13541,6 +13686,7 @@
           <a:lstStyle/>
           <a:p>
             <a:pPr algn="ctr"/>
+            <a:endParaRPr/>
           </a:p>
         </p:txBody>
       </p:sp>
@@ -13623,6 +13769,7 @@
           <a:lstStyle/>
           <a:p>
             <a:pPr algn="ctr"/>
+            <a:endParaRPr/>
           </a:p>
         </p:txBody>
       </p:sp>
@@ -13700,6 +13847,7 @@
           <a:lstStyle/>
           <a:p>
             <a:pPr algn="ctr"/>
+            <a:endParaRPr/>
           </a:p>
         </p:txBody>
       </p:sp>
@@ -13782,6 +13930,7 @@
           <a:lstStyle/>
           <a:p>
             <a:pPr algn="ctr"/>
+            <a:endParaRPr/>
           </a:p>
         </p:txBody>
       </p:sp>
@@ -13859,6 +14008,7 @@
           <a:lstStyle/>
           <a:p>
             <a:pPr algn="ctr"/>
+            <a:endParaRPr/>
           </a:p>
         </p:txBody>
       </p:sp>
@@ -13941,6 +14091,7 @@
           <a:lstStyle/>
           <a:p>
             <a:pPr algn="ctr"/>
+            <a:endParaRPr/>
           </a:p>
         </p:txBody>
       </p:sp>
@@ -14157,7 +14308,7 @@
 </file>
 
 <file path=ppt/slides/slide8.xml><?xml version="1.0" encoding="utf-8"?>
-<p:sld xmlns:a="http://schemas.openxmlformats.org/drawingml/2006/main" xmlns:p="http://schemas.openxmlformats.org/presentationml/2006/main" xmlns:r="http://schemas.openxmlformats.org/officeDocument/2006/relationships">
+<p:sld xmlns:a="http://schemas.openxmlformats.org/drawingml/2006/main" xmlns:r="http://schemas.openxmlformats.org/officeDocument/2006/relationships" xmlns:p="http://schemas.openxmlformats.org/presentationml/2006/main">
   <p:cSld>
     <p:bg>
       <p:bgPr>
@@ -14173,7 +14324,14 @@
         <p:cNvGrpSpPr/>
         <p:nvPr/>
       </p:nvGrpSpPr>
-      <p:grpSpPr/>
+      <p:grpSpPr>
+        <a:xfrm>
+          <a:off x="0" y="0"/>
+          <a:ext cx="0" cy="0"/>
+          <a:chOff x="0" y="0"/>
+          <a:chExt cx="0" cy="0"/>
+        </a:xfrm>
+      </p:grpSpPr>
       <p:sp>
         <p:nvSpPr>
           <p:cNvPr id="2" name="TextBox 1"/>
@@ -14282,6 +14440,7 @@
           <a:lstStyle/>
           <a:p>
             <a:pPr algn="ctr"/>
+            <a:endParaRPr/>
           </a:p>
         </p:txBody>
       </p:sp>
@@ -14327,6 +14486,7 @@
           <a:lstStyle/>
           <a:p>
             <a:pPr algn="ctr"/>
+            <a:endParaRPr/>
           </a:p>
         </p:txBody>
       </p:sp>
@@ -14370,6 +14530,7 @@
           <a:lstStyle/>
           <a:p>
             <a:pPr algn="ctr"/>
+            <a:endParaRPr/>
           </a:p>
         </p:txBody>
       </p:sp>
@@ -14481,6 +14642,7 @@
           <a:lstStyle/>
           <a:p>
             <a:pPr algn="ctr"/>
+            <a:endParaRPr/>
           </a:p>
         </p:txBody>
       </p:sp>
@@ -14600,6 +14762,7 @@
           <a:lstStyle/>
           <a:p>
             <a:pPr algn="ctr"/>
+            <a:endParaRPr/>
           </a:p>
         </p:txBody>
       </p:sp>
@@ -14643,6 +14806,7 @@
           <a:lstStyle/>
           <a:p>
             <a:pPr algn="ctr"/>
+            <a:endParaRPr/>
           </a:p>
         </p:txBody>
       </p:sp>
@@ -14754,6 +14918,7 @@
           <a:lstStyle/>
           <a:p>
             <a:pPr algn="ctr"/>
+            <a:endParaRPr/>
           </a:p>
         </p:txBody>
       </p:sp>
@@ -14873,6 +15038,7 @@
           <a:lstStyle/>
           <a:p>
             <a:pPr algn="ctr"/>
+            <a:endParaRPr/>
           </a:p>
         </p:txBody>
       </p:sp>
@@ -14916,6 +15082,7 @@
           <a:lstStyle/>
           <a:p>
             <a:pPr algn="ctr"/>
+            <a:endParaRPr/>
           </a:p>
         </p:txBody>
       </p:sp>
@@ -15027,6 +15194,7 @@
           <a:lstStyle/>
           <a:p>
             <a:pPr algn="ctr"/>
+            <a:endParaRPr/>
           </a:p>
         </p:txBody>
       </p:sp>
@@ -15146,6 +15314,7 @@
           <a:lstStyle/>
           <a:p>
             <a:pPr algn="ctr"/>
+            <a:endParaRPr/>
           </a:p>
         </p:txBody>
       </p:sp>
@@ -15189,6 +15358,7 @@
           <a:lstStyle/>
           <a:p>
             <a:pPr algn="ctr"/>
+            <a:endParaRPr/>
           </a:p>
         </p:txBody>
       </p:sp>
@@ -15300,6 +15470,7 @@
           <a:lstStyle/>
           <a:p>
             <a:pPr algn="ctr"/>
+            <a:endParaRPr/>
           </a:p>
         </p:txBody>
       </p:sp>
@@ -15385,6 +15556,7 @@
           <a:lstStyle/>
           <a:p>
             <a:pPr algn="ctr"/>
+            <a:endParaRPr/>
           </a:p>
         </p:txBody>
       </p:sp>
@@ -15771,7 +15943,7 @@
 </file>
 
 <file path=ppt/slides/slide9.xml><?xml version="1.0" encoding="utf-8"?>
-<p:sld xmlns:a="http://schemas.openxmlformats.org/drawingml/2006/main" xmlns:p="http://schemas.openxmlformats.org/presentationml/2006/main" xmlns:r="http://schemas.openxmlformats.org/officeDocument/2006/relationships">
+<p:sld xmlns:a="http://schemas.openxmlformats.org/drawingml/2006/main" xmlns:r="http://schemas.openxmlformats.org/officeDocument/2006/relationships" xmlns:p="http://schemas.openxmlformats.org/presentationml/2006/main">
   <p:cSld>
     <p:bg>
       <p:bgPr>
@@ -15787,7 +15959,14 @@
         <p:cNvGrpSpPr/>
         <p:nvPr/>
       </p:nvGrpSpPr>
-      <p:grpSpPr/>
+      <p:grpSpPr>
+        <a:xfrm>
+          <a:off x="0" y="0"/>
+          <a:ext cx="0" cy="0"/>
+          <a:chOff x="0" y="0"/>
+          <a:chExt cx="0" cy="0"/>
+        </a:xfrm>
+      </p:grpSpPr>
       <p:sp>
         <p:nvSpPr>
           <p:cNvPr id="2" name="TextBox 1"/>
@@ -15896,6 +16075,7 @@
           <a:lstStyle/>
           <a:p>
             <a:pPr algn="ctr"/>
+            <a:endParaRPr/>
           </a:p>
         </p:txBody>
       </p:sp>
@@ -15941,6 +16121,7 @@
           <a:lstStyle/>
           <a:p>
             <a:pPr algn="ctr"/>
+            <a:endParaRPr/>
           </a:p>
         </p:txBody>
       </p:sp>
@@ -16018,6 +16199,7 @@
           <a:lstStyle/>
           <a:p>
             <a:pPr algn="ctr"/>
+            <a:endParaRPr/>
           </a:p>
         </p:txBody>
       </p:sp>
@@ -16131,6 +16313,7 @@
           <a:lstStyle/>
           <a:p>
             <a:pPr algn="ctr"/>
+            <a:endParaRPr/>
           </a:p>
         </p:txBody>
       </p:sp>
@@ -16208,6 +16391,7 @@
           <a:lstStyle/>
           <a:p>
             <a:pPr algn="ctr"/>
+            <a:endParaRPr/>
           </a:p>
         </p:txBody>
       </p:sp>
@@ -16321,6 +16505,7 @@
           <a:lstStyle/>
           <a:p>
             <a:pPr algn="ctr"/>
+            <a:endParaRPr/>
           </a:p>
         </p:txBody>
       </p:sp>
@@ -16398,6 +16583,7 @@
           <a:lstStyle/>
           <a:p>
             <a:pPr algn="ctr"/>
+            <a:endParaRPr/>
           </a:p>
         </p:txBody>
       </p:sp>
@@ -16511,6 +16697,7 @@
           <a:lstStyle/>
           <a:p>
             <a:pPr algn="ctr"/>
+            <a:endParaRPr/>
           </a:p>
         </p:txBody>
       </p:sp>
@@ -16588,6 +16775,7 @@
           <a:lstStyle/>
           <a:p>
             <a:pPr algn="ctr"/>
+            <a:endParaRPr/>
           </a:p>
         </p:txBody>
       </p:sp>
@@ -16701,6 +16889,7 @@
           <a:lstStyle/>
           <a:p>
             <a:pPr algn="ctr"/>
+            <a:endParaRPr/>
           </a:p>
         </p:txBody>
       </p:sp>
@@ -16778,6 +16967,7 @@
           <a:lstStyle/>
           <a:p>
             <a:pPr algn="ctr"/>
+            <a:endParaRPr/>
           </a:p>
         </p:txBody>
       </p:sp>
@@ -18183,6 +18373,7 @@
           <a:lstStyle/>
           <a:p>
             <a:pPr algn="ctr"/>
+            <a:endParaRPr/>
           </a:p>
         </p:txBody>
       </p:sp>

</xml_diff>